<commit_message>
fix(deck): shorter RL slide title so it fits on one line
</commit_message>
<xml_diff>
--- a/deck/ETS_ML2_Kesegaran_Ayam.pptx
+++ b/deck/ETS_ML2_Kesegaran_Ayam.pptx
@@ -118,7 +118,7 @@
   <p:extLst>
     <p:ext uri="{521415D9-36F7-43E2-AB2F-B90AF26B5E84}">
       <p14:sectionLst xmlns:p14="http://schemas.microsoft.com/office/powerpoint/2010/main">
-        <p14:section name="Erlangga: latar belakang, data, pengolahan" id="{2c4b4686-aa44-bc9b-9452-618d8e39dd71}">
+        <p14:section name="Erlangga: latar belakang, data, pengolahan" id="{98ddf7c6-99e0-55af-7e2f-2cbdcbcef629}">
           <p14:sldIdLst>
             <p14:sldId id="256"/>
             <p14:sldId id="257"/>
@@ -126,14 +126,14 @@
             <p14:sldId id="259"/>
           </p14:sldIdLst>
         </p14:section>
-        <p14:section name="Michael: uji jujur, ensemble, augmentasi" id="{b98aa088-c491-e13c-ac8e-08bbca826713}">
+        <p14:section name="Michael: uji jujur, ensemble, augmentasi" id="{430c9fd4-bce5-2633-8d03-94dff38c794f}">
           <p14:sldIdLst>
             <p14:sldId id="260"/>
             <p14:sldId id="261"/>
             <p14:sldId id="262"/>
           </p14:sldIdLst>
         </p14:section>
-        <p14:section name="Rijal: reinforcement, diskusi, kesimpulan" id="{7891ed85-8d21-ed7e-ddb5-5e6e3cd6377f}">
+        <p14:section name="Rijal: reinforcement, diskusi, kesimpulan" id="{a6b2a6aa-f8d8-f4d2-1183-c186232e3384}">
           <p14:sldIdLst>
             <p14:sldId id="263"/>
             <p14:sldId id="264"/>
@@ -9529,7 +9529,7 @@
                 <a:ea typeface="Cambria" pitchFamily="34" charset="-122"/>
                 <a:cs typeface="Cambria" pitchFamily="34" charset="-120"/>
               </a:rPr>
-              <a:t>Reinforcement learning: agen pengambil keputusan</a:t>
+              <a:t>Reinforcement learning: agen keputusan</a:t>
             </a:r>
             <a:endParaRPr lang="en-US" sz="3000" dirty="0"/>
           </a:p>

</xml_diff>